<commit_message>
Use GPT-5 mini and Claude Opus 5 as the weak/strong model pair
Replaces GPT-4.1 and Claude Sonnet 4.5 throughout the handouts, the
facilitator guide and the deck, matching what is actually licensed.

Adds a calibration note to the Exercise 2 answer key: the predicted
failure modes were written against the old pairing, and GPT-5 mini
will fail less spectacularly than GPT-4.1 did. Plausible-looking code
that still answers the six ambiguities silently is a better
demonstration than an NPE, so the review should steer toward what was
decided rather than what broke.

Co-Authored-By: Claude Opus 5 (1M context) <noreply@anthropic.com>
Claude-Session: https://claude.ai/code/session_01N26J6xbGQ7Rhvhxeagpwhz
</commit_message>
<xml_diff>
--- a/docs/facilitator/bootcamp-deck.pptx
+++ b/docs/facilitator/bootcamp-deck.pptx
@@ -1170,6 +1170,18 @@
           <a:p>
             <a:r>
               <a:t>Roughly in order of frequency. The class name NotificationService alone is enough to trigger the invented email transport.</a:t>
+            </a:r>
+          </a:p>
+          <a:p/>
+          <a:p>
+            <a:r>
+              <a:t>CALIBRATION: this list was written against GPT-4.1 vs Sonnet 4.5. With GPT-5 mini at the weak end, expect fewer outright NPEs and more plausible-looking code that still answers the six ambiguities silently. That is a better demonstration, not a worse one — "it compiles and looks reasonable" is the failure mode people actually meet at work. Steer the review toward WHAT WAS DECIDED rather than what broke.</a:t>
+            </a:r>
+          </a:p>
+          <a:p/>
+          <a:p>
+            <a:r>
+              <a:t>With Opus 5 at the strong end, it may ask a clarifying question or refuse to invent a scheduler. Name it when it happens: the model did the Refine stage on its own, partially, because nobody else had. Perfect setup for Exercise 4.</a:t>
             </a:r>
           </a:p>
           <a:p/>
@@ -8402,7 +8414,7 @@
                 </a:solidFill>
                 <a:latin typeface="Calibri"/>
               </a:rPr>
-              <a:t>•  Run 1 — GPT-4.1</a:t>
+              <a:t>•  Run 1 — GPT-5 mini</a:t>
             </a:r>
           </a:p>
           <a:p>
@@ -8620,7 +8632,7 @@
                 </a:solidFill>
                 <a:latin typeface="Calibri"/>
               </a:rPr>
-              <a:t>Commit after every run:  git add -A &amp;&amp; git commit -m "ex2: gpt-4.1, no instructions"</a:t>
+              <a:t>Commit after every run:  git add -A &amp;&amp; git commit -m "ex2: gpt-5-mini, no instructions"</a:t>
             </a:r>
           </a:p>
         </p:txBody>

</xml_diff>